<commit_message>
Repair 3.2.7 presentatie: embed missing graphs on slides 5 and 10
The presentation file contained no embedded media (ppt/media/ was
empty), while slides 5 and 10 had grey placeholder boxes labelled
"Grafiek: V/A-diagram" and "Grafiek: reactielijnen". Sibling paragraph
presentations (3.2.1-3.2.6) all embed 2-3 PNG graphs.

Generated two matplotlib PNG graphs and embedded them:

- Slide 5: V/A-diagram monopolie vs. volkomen concurrentie with
  consumenten-/producentensurplus en Harbergerdriehoek.
- Slide 10: Cournot-duopolie reactielijnen voor en na
  capaciteitsuitbreiding met Nash-evenwichten.

For each slide: replaced the grey container + placeholder text with
a <p:pic> element pointing to the embedded image, registered the
image relationship in the slide's .rels file, and added the PNG to
ppt/media/. Verified with python-pptx that both slides now contain
exactly one picture shape and the file is a valid .pptx.
</commit_message>
<xml_diff>
--- a/3.2 Hoofdstuk 2 - Marktvormen en hun marktevenwicht/3.2.7 Paragraaf 7 - Toepassen/2. Leren/3.2.7 Toepassen – presentatie.pptx
+++ b/3.2 Hoofdstuk 2 - Marktvormen en hun marktevenwicht/3.2.7 Paragraaf 7 - Toepassen/2. Leren/3.2.7 Toepassen – presentatie.pptx
@@ -2282,106 +2282,30 @@
           </a:p>
         </p:txBody>
       </p:sp>
-      <p:sp>
-        <p:nvSpPr>
-          <p:cNvPr id="3" name="Shape 1"/>
-          <p:cNvSpPr/>
-          <p:nvPr/>
-        </p:nvSpPr>
+      <p:pic>
+        <p:nvPicPr>
+          <p:cNvPr id="99910" name="Graph10"/>
+          <p:cNvPicPr>
+            <a:picLocks noChangeAspect="1"/>
+          </p:cNvPicPr>
+          <p:nvPr/>
+        </p:nvPicPr>
+        <p:blipFill>
+          <a:blip r:embed="rId3"/>
+          <a:stretch>
+            <a:fillRect/>
+          </a:stretch>
+        </p:blipFill>
         <p:spPr>
           <a:xfrm>
             <a:off x="457200" y="1005840"/>
             <a:ext cx="5029200" cy="3657600"/>
           </a:xfrm>
           <a:prstGeom prst="rect">
-            <a:avLst>
-              <a:gd name="adj" fmla="val 1250"/>
-            </a:avLst>
-          </a:prstGeom>
-          <a:solidFill>
-            <a:srgbClr val="F7F8FA"/>
-          </a:solidFill>
-          <a:ln w="6350">
-            <a:solidFill>
-              <a:srgbClr val="CBD5E0"/>
-            </a:solidFill>
-            <a:prstDash val="solid"/>
-          </a:ln>
-        </p:spPr>
-      </p:sp>
-      <p:sp>
-        <p:nvSpPr>
-          <p:cNvPr id="4" name="Text 2"/>
-          <p:cNvSpPr/>
-          <p:nvPr/>
-        </p:nvSpPr>
-        <p:spPr>
-          <a:xfrm>
-            <a:off x="457200" y="2103120"/>
-            <a:ext cx="5029200" cy="1371600"/>
-          </a:xfrm>
-          <a:prstGeom prst="rect">
-            <a:avLst/>
-          </a:prstGeom>
-          <a:noFill/>
-          <a:ln/>
-        </p:spPr>
-        <p:txBody>
-          <a:bodyPr wrap="square" rtlCol="0" anchor="ctr"/>
-          <a:lstStyle/>
-          <a:p>
-            <a:pPr algn="ctr" indent="0" marL="0">
-              <a:buNone/>
-            </a:pPr>
-            <a:r>
-              <a:rPr lang="en-US" sz="1300" i="1" dirty="0">
-                <a:solidFill>
-                  <a:srgbClr val="718096"/>
-                </a:solidFill>
-                <a:latin typeface="Arial" pitchFamily="34" charset="0"/>
-                <a:ea typeface="Arial" pitchFamily="34" charset="-122"/>
-                <a:cs typeface="Arial" pitchFamily="34" charset="-120"/>
-              </a:rPr>
-              <a:t>Grafiek: reactielijnen</a:t>
-            </a:r>
-            <a:endParaRPr lang="en-US" sz="1300" dirty="0"/>
-          </a:p>
-          <a:p>
-            <a:pPr algn="ctr" indent="0" marL="0">
-              <a:buNone/>
-            </a:pPr>
-            <a:r>
-              <a:rPr lang="en-US" sz="1300" i="1" dirty="0">
-                <a:solidFill>
-                  <a:srgbClr val="718096"/>
-                </a:solidFill>
-                <a:latin typeface="Arial" pitchFamily="34" charset="0"/>
-                <a:ea typeface="Arial" pitchFamily="34" charset="-122"/>
-                <a:cs typeface="Arial" pitchFamily="34" charset="-120"/>
-              </a:rPr>
-              <a:t>voor en na uitbreiding</a:t>
-            </a:r>
-            <a:endParaRPr lang="en-US" sz="1300" dirty="0"/>
-          </a:p>
-          <a:p>
-            <a:pPr algn="ctr" indent="0" marL="0">
-              <a:buNone/>
-            </a:pPr>
-            <a:r>
-              <a:rPr lang="en-US" sz="1300" i="1" dirty="0">
-                <a:solidFill>
-                  <a:srgbClr val="718096"/>
-                </a:solidFill>
-                <a:latin typeface="Arial" pitchFamily="34" charset="0"/>
-                <a:ea typeface="Arial" pitchFamily="34" charset="-122"/>
-                <a:cs typeface="Arial" pitchFamily="34" charset="-120"/>
-              </a:rPr>
-              <a:t>Verschuiving evenwicht</a:t>
-            </a:r>
-            <a:endParaRPr lang="en-US" sz="1300" dirty="0"/>
-          </a:p>
-        </p:txBody>
-      </p:sp>
+            <a:avLst/>
+          </a:prstGeom>
+        </p:spPr>
+      </p:pic>
       <p:sp>
         <p:nvSpPr>
           <p:cNvPr id="5" name="Shape 3"/>
@@ -9426,106 +9350,30 @@
           </a:p>
         </p:txBody>
       </p:sp>
-      <p:sp>
-        <p:nvSpPr>
-          <p:cNvPr id="3" name="Shape 1"/>
-          <p:cNvSpPr/>
-          <p:nvPr/>
-        </p:nvSpPr>
+      <p:pic>
+        <p:nvPicPr>
+          <p:cNvPr id="9995" name="Graph5"/>
+          <p:cNvPicPr>
+            <a:picLocks noChangeAspect="1"/>
+          </p:cNvPicPr>
+          <p:nvPr/>
+        </p:nvPicPr>
+        <p:blipFill>
+          <a:blip r:embed="rId3"/>
+          <a:stretch>
+            <a:fillRect/>
+          </a:stretch>
+        </p:blipFill>
         <p:spPr>
           <a:xfrm>
             <a:off x="457200" y="1005840"/>
             <a:ext cx="5029200" cy="3657600"/>
           </a:xfrm>
           <a:prstGeom prst="rect">
-            <a:avLst>
-              <a:gd name="adj" fmla="val 1250"/>
-            </a:avLst>
-          </a:prstGeom>
-          <a:solidFill>
-            <a:srgbClr val="F7F8FA"/>
-          </a:solidFill>
-          <a:ln w="6350">
-            <a:solidFill>
-              <a:srgbClr val="CBD5E0"/>
-            </a:solidFill>
-            <a:prstDash val="solid"/>
-          </a:ln>
-        </p:spPr>
-      </p:sp>
-      <p:sp>
-        <p:nvSpPr>
-          <p:cNvPr id="4" name="Text 2"/>
-          <p:cNvSpPr/>
-          <p:nvPr/>
-        </p:nvSpPr>
-        <p:spPr>
-          <a:xfrm>
-            <a:off x="457200" y="2103120"/>
-            <a:ext cx="5029200" cy="1371600"/>
-          </a:xfrm>
-          <a:prstGeom prst="rect">
-            <a:avLst/>
-          </a:prstGeom>
-          <a:noFill/>
-          <a:ln/>
-        </p:spPr>
-        <p:txBody>
-          <a:bodyPr wrap="square" rtlCol="0" anchor="ctr"/>
-          <a:lstStyle/>
-          <a:p>
-            <a:pPr algn="ctr" indent="0" marL="0">
-              <a:buNone/>
-            </a:pPr>
-            <a:r>
-              <a:rPr lang="en-US" sz="1300" i="1" dirty="0">
-                <a:solidFill>
-                  <a:srgbClr val="718096"/>
-                </a:solidFill>
-                <a:latin typeface="Arial" pitchFamily="34" charset="0"/>
-                <a:ea typeface="Arial" pitchFamily="34" charset="-122"/>
-                <a:cs typeface="Arial" pitchFamily="34" charset="-120"/>
-              </a:rPr>
-              <a:t>Grafiek: V/A-diagram</a:t>
-            </a:r>
-            <a:endParaRPr lang="en-US" sz="1300" dirty="0"/>
-          </a:p>
-          <a:p>
-            <a:pPr algn="ctr" indent="0" marL="0">
-              <a:buNone/>
-            </a:pPr>
-            <a:r>
-              <a:rPr lang="en-US" sz="1300" i="1" dirty="0">
-                <a:solidFill>
-                  <a:srgbClr val="718096"/>
-                </a:solidFill>
-                <a:latin typeface="Arial" pitchFamily="34" charset="0"/>
-                <a:ea typeface="Arial" pitchFamily="34" charset="-122"/>
-                <a:cs typeface="Arial" pitchFamily="34" charset="-120"/>
-              </a:rPr>
-              <a:t>Monopolie vs. VC</a:t>
-            </a:r>
-            <a:endParaRPr lang="en-US" sz="1300" dirty="0"/>
-          </a:p>
-          <a:p>
-            <a:pPr algn="ctr" indent="0" marL="0">
-              <a:buNone/>
-            </a:pPr>
-            <a:r>
-              <a:rPr lang="en-US" sz="1300" i="1" dirty="0">
-                <a:solidFill>
-                  <a:srgbClr val="718096"/>
-                </a:solidFill>
-                <a:latin typeface="Arial" pitchFamily="34" charset="0"/>
-                <a:ea typeface="Arial" pitchFamily="34" charset="-122"/>
-                <a:cs typeface="Arial" pitchFamily="34" charset="-120"/>
-              </a:rPr>
-              <a:t>CS, PS, Harbergerdriehoek</a:t>
-            </a:r>
-            <a:endParaRPr lang="en-US" sz="1300" dirty="0"/>
-          </a:p>
-        </p:txBody>
-      </p:sp>
+            <a:avLst/>
+          </a:prstGeom>
+        </p:spPr>
+      </p:pic>
       <p:sp>
         <p:nvSpPr>
           <p:cNvPr id="5" name="Shape 3"/>

</xml_diff>

<commit_message>
Remove Cournot content from 3.2.7 Toepassen presentation
Slides 9 (Cournot-duopolie: reactielijnen) and 10 (Surplus bij
capaciteitsuitbreiding - shift of Cournot reaction curves) are
removed, along with the two Cournot learning-goal bullets on slide 2
("Cournot-duopolie oplossen" and "Reactielijnen en Nash-evenwicht").

Also deletes the embedded Cournot graph (image-10-1.png) and cleans up
relationships and content-types overrides. The V/A-diagram on the
remaining slide 5 is kept. Presentation shrinks from 13 to 11 slides.
</commit_message>
<xml_diff>
--- a/3.2 Hoofdstuk 2 - Marktvormen en hun marktevenwicht/3.2.7 Paragraaf 7 - Toepassen/2. Leren/3.2.7 Toepassen – presentatie.pptx
+++ b/3.2 Hoofdstuk 2 - Marktvormen en hun marktevenwicht/3.2.7 Paragraaf 7 - Toepassen/2. Leren/3.2.7 Toepassen – presentatie.pptx
@@ -13,8 +13,6 @@
     <p:sldId id="261" r:id="rId7"/>
     <p:sldId id="262" r:id="rId8"/>
     <p:sldId id="263" r:id="rId9"/>
-    <p:sldId id="264" r:id="rId10"/>
-    <p:sldId id="265" r:id="rId11"/>
     <p:sldId id="266" r:id="rId12"/>
     <p:sldId id="267" r:id="rId13"/>
     <p:sldId id="268" r:id="rId14"/>
@@ -556,94 +554,6 @@
 </p:notes>
 </file>
 
-<file path=ppt/notesSlides/notesSlide10.xml><?xml version="1.0" encoding="utf-8"?>
-<p:notes xmlns:a="http://schemas.openxmlformats.org/drawingml/2006/main" xmlns:r="http://schemas.openxmlformats.org/officeDocument/2006/relationships" xmlns:p="http://schemas.openxmlformats.org/presentationml/2006/main">
-  <p:cSld>
-    <p:spTree>
-      <p:nvGrpSpPr>
-        <p:cNvPr id="1" name=""/>
-        <p:cNvGrpSpPr/>
-        <p:nvPr/>
-      </p:nvGrpSpPr>
-      <p:grpSpPr>
-        <a:xfrm>
-          <a:off x="0" y="0"/>
-          <a:ext cx="0" cy="0"/>
-          <a:chOff x="0" y="0"/>
-          <a:chExt cx="0" cy="0"/>
-        </a:xfrm>
-      </p:grpSpPr>
-      <p:sp>
-        <p:nvSpPr>
-          <p:cNvPr id="2" name="Slide Image Placeholder 1"/>
-          <p:cNvSpPr>
-            <a:spLocks noGrp="1" noRot="1" noChangeAspect="1"/>
-          </p:cNvSpPr>
-          <p:nvPr>
-            <p:ph type="sldImg"/>
-          </p:nvPr>
-        </p:nvSpPr>
-        <p:spPr/>
-      </p:sp>
-      <p:sp>
-        <p:nvSpPr>
-          <p:cNvPr id="3" name="Notes Placeholder 2"/>
-          <p:cNvSpPr>
-            <a:spLocks noGrp="1"/>
-          </p:cNvSpPr>
-          <p:nvPr>
-            <p:ph type="body" idx="1"/>
-          </p:nvPr>
-        </p:nvSpPr>
-        <p:spPr/>
-        <p:txBody>
-          <a:bodyPr/>
-          <a:lstStyle/>
-          <a:p>
-            <a:r>
-              <a:rPr lang="en-US" dirty="0"/>
-              <a:t>Als een bestaande aanbieder zijn capaciteit uitbreidt, verschuift zijn reactielijn. Dit verandert het evenwicht: totale productie stijgt, prijs daalt, en het surplus herverdeelt zich.</a:t>
-            </a:r>
-            <a:endParaRPr lang="en-US" dirty="0"/>
-          </a:p>
-        </p:txBody>
-      </p:sp>
-      <p:sp>
-        <p:nvSpPr>
-          <p:cNvPr id="4" name="Slide Number Placeholder 3"/>
-          <p:cNvSpPr>
-            <a:spLocks noGrp="1"/>
-          </p:cNvSpPr>
-          <p:nvPr>
-            <p:ph type="sldNum" sz="quarter" idx="10"/>
-          </p:nvPr>
-        </p:nvSpPr>
-        <p:spPr/>
-        <p:txBody>
-          <a:bodyPr/>
-          <a:lstStyle/>
-          <a:p>
-            <a:fld id="{F7021451-1387-4CA6-816F-3879F97B5CBC}" type="slidenum">
-              <a:rPr lang="en-US"/>
-              <a:t>10</a:t>
-            </a:fld>
-            <a:endParaRPr lang="en-US"/>
-          </a:p>
-        </p:txBody>
-      </p:sp>
-    </p:spTree>
-    <p:extLst>
-      <p:ext uri="{BB962C8B-B14F-4D97-AF65-F5344CB8AC3E}">
-        <p14:creationId xmlns:p14="http://schemas.microsoft.com/office/powerpoint/2010/main" val="1024086991"/>
-      </p:ext>
-    </p:extLst>
-  </p:cSld>
-  <p:clrMapOvr>
-    <a:masterClrMapping/>
-  </p:clrMapOvr>
-</p:notes>
-</file>
-
 <file path=ppt/notesSlides/notesSlide11.xml><?xml version="1.0" encoding="utf-8"?>
 <p:notes xmlns:a="http://schemas.openxmlformats.org/drawingml/2006/main" xmlns:r="http://schemas.openxmlformats.org/officeDocument/2006/relationships" xmlns:p="http://schemas.openxmlformats.org/presentationml/2006/main">
   <p:cSld>
@@ -1506,94 +1416,6 @@
             <a:fld id="{F7021451-1387-4CA6-816F-3879F97B5CBC}" type="slidenum">
               <a:rPr lang="en-US"/>
               <a:t>8</a:t>
-            </a:fld>
-            <a:endParaRPr lang="en-US"/>
-          </a:p>
-        </p:txBody>
-      </p:sp>
-    </p:spTree>
-    <p:extLst>
-      <p:ext uri="{BB962C8B-B14F-4D97-AF65-F5344CB8AC3E}">
-        <p14:creationId xmlns:p14="http://schemas.microsoft.com/office/powerpoint/2010/main" val="1024086991"/>
-      </p:ext>
-    </p:extLst>
-  </p:cSld>
-  <p:clrMapOvr>
-    <a:masterClrMapping/>
-  </p:clrMapOvr>
-</p:notes>
-</file>
-
-<file path=ppt/notesSlides/notesSlide9.xml><?xml version="1.0" encoding="utf-8"?>
-<p:notes xmlns:a="http://schemas.openxmlformats.org/drawingml/2006/main" xmlns:r="http://schemas.openxmlformats.org/officeDocument/2006/relationships" xmlns:p="http://schemas.openxmlformats.org/presentationml/2006/main">
-  <p:cSld>
-    <p:spTree>
-      <p:nvGrpSpPr>
-        <p:cNvPr id="1" name=""/>
-        <p:cNvGrpSpPr/>
-        <p:nvPr/>
-      </p:nvGrpSpPr>
-      <p:grpSpPr>
-        <a:xfrm>
-          <a:off x="0" y="0"/>
-          <a:ext cx="0" cy="0"/>
-          <a:chOff x="0" y="0"/>
-          <a:chExt cx="0" cy="0"/>
-        </a:xfrm>
-      </p:grpSpPr>
-      <p:sp>
-        <p:nvSpPr>
-          <p:cNvPr id="2" name="Slide Image Placeholder 1"/>
-          <p:cNvSpPr>
-            <a:spLocks noGrp="1" noRot="1" noChangeAspect="1"/>
-          </p:cNvSpPr>
-          <p:nvPr>
-            <p:ph type="sldImg"/>
-          </p:nvPr>
-        </p:nvSpPr>
-        <p:spPr/>
-      </p:sp>
-      <p:sp>
-        <p:nvSpPr>
-          <p:cNvPr id="3" name="Notes Placeholder 2"/>
-          <p:cNvSpPr>
-            <a:spLocks noGrp="1"/>
-          </p:cNvSpPr>
-          <p:nvPr>
-            <p:ph type="body" idx="1"/>
-          </p:nvPr>
-        </p:nvSpPr>
-        <p:spPr/>
-        <p:txBody>
-          <a:bodyPr/>
-          <a:lstStyle/>
-          <a:p>
-            <a:r>
-              <a:rPr lang="en-US" dirty="0"/>
-              <a:t>Cournot-duopolie: twee aanbieders kiezen tegelijkertijd hun hoeveelheid. De reactielijnen geven aan hoeveel je produceert gegeven de productie van de ander. Het Nash-evenwicht is op het snijpunt van de reactielijnen.</a:t>
-            </a:r>
-            <a:endParaRPr lang="en-US" dirty="0"/>
-          </a:p>
-        </p:txBody>
-      </p:sp>
-      <p:sp>
-        <p:nvSpPr>
-          <p:cNvPr id="4" name="Slide Number Placeholder 3"/>
-          <p:cNvSpPr>
-            <a:spLocks noGrp="1"/>
-          </p:cNvSpPr>
-          <p:nvPr>
-            <p:ph type="sldNum" sz="quarter" idx="10"/>
-          </p:nvPr>
-        </p:nvSpPr>
-        <p:spPr/>
-        <p:txBody>
-          <a:bodyPr/>
-          <a:lstStyle/>
-          <a:p>
-            <a:fld id="{F7021451-1387-4CA6-816F-3879F97B5CBC}" type="slidenum">
-              <a:rPr lang="en-US"/>
-              <a:t>9</a:t>
             </a:fld>
             <a:endParaRPr lang="en-US"/>
           </a:p>
@@ -2226,300 +2048,6 @@
 </p:sld>
 </file>
 
-<file path=ppt/slides/slide10.xml><?xml version="1.0" encoding="utf-8"?>
-<p:sld xmlns:a="http://schemas.openxmlformats.org/drawingml/2006/main" xmlns:r="http://schemas.openxmlformats.org/officeDocument/2006/relationships" xmlns:p="http://schemas.openxmlformats.org/presentationml/2006/main">
-  <p:cSld name="Slide 10">
-    <p:spTree>
-      <p:nvGrpSpPr>
-        <p:cNvPr id="1" name=""/>
-        <p:cNvGrpSpPr/>
-        <p:nvPr/>
-      </p:nvGrpSpPr>
-      <p:grpSpPr>
-        <a:xfrm>
-          <a:off x="0" y="0"/>
-          <a:ext cx="0" cy="0"/>
-          <a:chOff x="0" y="0"/>
-          <a:chExt cx="0" cy="0"/>
-        </a:xfrm>
-      </p:grpSpPr>
-      <p:sp>
-        <p:nvSpPr>
-          <p:cNvPr id="2" name="Text 0"/>
-          <p:cNvSpPr/>
-          <p:nvPr/>
-        </p:nvSpPr>
-        <p:spPr>
-          <a:xfrm>
-            <a:off x="457200" y="0"/>
-            <a:ext cx="8229600" cy="685800"/>
-          </a:xfrm>
-          <a:prstGeom prst="rect">
-            <a:avLst/>
-          </a:prstGeom>
-          <a:noFill/>
-          <a:ln/>
-        </p:spPr>
-        <p:txBody>
-          <a:bodyPr wrap="square" rtlCol="0" anchor="ctr"/>
-          <a:lstStyle/>
-          <a:p>
-            <a:pPr indent="0" marL="0">
-              <a:buNone/>
-            </a:pPr>
-            <a:r>
-              <a:rPr lang="en-US" sz="2400" b="1" dirty="0">
-                <a:solidFill>
-                  <a:srgbClr val="FFFFFF"/>
-                </a:solidFill>
-                <a:latin typeface="Arial" pitchFamily="34" charset="0"/>
-                <a:ea typeface="Arial" pitchFamily="34" charset="-122"/>
-                <a:cs typeface="Arial" pitchFamily="34" charset="-120"/>
-              </a:rPr>
-              <a:t>Surplus bij capaciteitsuitbreiding</a:t>
-            </a:r>
-            <a:endParaRPr lang="en-US" sz="2400" dirty="0"/>
-          </a:p>
-        </p:txBody>
-      </p:sp>
-      <p:pic>
-        <p:nvPicPr>
-          <p:cNvPr id="99910" name="Graph10"/>
-          <p:cNvPicPr>
-            <a:picLocks noChangeAspect="1"/>
-          </p:cNvPicPr>
-          <p:nvPr/>
-        </p:nvPicPr>
-        <p:blipFill>
-          <a:blip r:embed="rId3"/>
-          <a:stretch>
-            <a:fillRect/>
-          </a:stretch>
-        </p:blipFill>
-        <p:spPr>
-          <a:xfrm>
-            <a:off x="457200" y="1005840"/>
-            <a:ext cx="5029200" cy="3657600"/>
-          </a:xfrm>
-          <a:prstGeom prst="rect">
-            <a:avLst/>
-          </a:prstGeom>
-        </p:spPr>
-      </p:pic>
-      <p:sp>
-        <p:nvSpPr>
-          <p:cNvPr id="5" name="Shape 3"/>
-          <p:cNvSpPr/>
-          <p:nvPr/>
-        </p:nvSpPr>
-        <p:spPr>
-          <a:xfrm>
-            <a:off x="5760720" y="1005840"/>
-            <a:ext cx="2926080" cy="3657600"/>
-          </a:xfrm>
-          <a:prstGeom prst="rect">
-            <a:avLst>
-              <a:gd name="adj" fmla="val 1563"/>
-            </a:avLst>
-          </a:prstGeom>
-          <a:solidFill>
-            <a:srgbClr val="F9F6F1"/>
-          </a:solidFill>
-          <a:ln/>
-          <a:effectLst>
-            <a:outerShdw sx="100000" sy="100000" kx="0" ky="0" algn="bl" rotWithShape="0" blurRad="76200" dist="25400" dir="8100000">
-              <a:srgbClr val="000000">
-                <a:alpha val="10000"/>
-              </a:srgbClr>
-            </a:outerShdw>
-          </a:effectLst>
-        </p:spPr>
-      </p:sp>
-      <p:sp>
-        <p:nvSpPr>
-          <p:cNvPr id="6" name="Shape 4"/>
-          <p:cNvSpPr/>
-          <p:nvPr/>
-        </p:nvSpPr>
-        <p:spPr>
-          <a:xfrm>
-            <a:off x="5760720" y="1005840"/>
-            <a:ext cx="54864" cy="3657600"/>
-          </a:xfrm>
-          <a:prstGeom prst="rect">
-            <a:avLst/>
-          </a:prstGeom>
-          <a:solidFill>
-            <a:srgbClr val="1A5276"/>
-          </a:solidFill>
-          <a:ln/>
-        </p:spPr>
-      </p:sp>
-      <p:sp>
-        <p:nvSpPr>
-          <p:cNvPr id="7" name="Text 5"/>
-          <p:cNvSpPr/>
-          <p:nvPr/>
-        </p:nvSpPr>
-        <p:spPr>
-          <a:xfrm>
-            <a:off x="5943600" y="1115568"/>
-            <a:ext cx="2606040" cy="365760"/>
-          </a:xfrm>
-          <a:prstGeom prst="rect">
-            <a:avLst/>
-          </a:prstGeom>
-          <a:noFill/>
-          <a:ln/>
-        </p:spPr>
-        <p:txBody>
-          <a:bodyPr wrap="square" rtlCol="0" anchor="t"/>
-          <a:lstStyle/>
-          <a:p>
-            <a:pPr indent="0" marL="0">
-              <a:buNone/>
-            </a:pPr>
-            <a:r>
-              <a:rPr lang="en-US" sz="1800" b="1" dirty="0">
-                <a:solidFill>
-                  <a:srgbClr val="1A5276"/>
-                </a:solidFill>
-                <a:latin typeface="Arial" pitchFamily="34" charset="0"/>
-                <a:ea typeface="Arial" pitchFamily="34" charset="-122"/>
-                <a:cs typeface="Arial" pitchFamily="34" charset="-120"/>
-              </a:rPr>
-              <a:t>Effect</a:t>
-            </a:r>
-            <a:endParaRPr lang="en-US" sz="1800" dirty="0"/>
-          </a:p>
-        </p:txBody>
-      </p:sp>
-      <p:sp>
-        <p:nvSpPr>
-          <p:cNvPr id="8" name="Text 6"/>
-          <p:cNvSpPr/>
-          <p:nvPr/>
-        </p:nvSpPr>
-        <p:spPr>
-          <a:xfrm>
-            <a:off x="5943600" y="1508760"/>
-            <a:ext cx="2606040" cy="3017520"/>
-          </a:xfrm>
-          <a:prstGeom prst="rect">
-            <a:avLst/>
-          </a:prstGeom>
-          <a:noFill/>
-          <a:ln/>
-        </p:spPr>
-        <p:txBody>
-          <a:bodyPr wrap="square" rtlCol="0" anchor="t"/>
-          <a:lstStyle/>
-          <a:p>
-            <a:pPr algn="l" indent="0" marL="0">
-              <a:lnSpc>
-                <a:spcPct val="115000"/>
-              </a:lnSpc>
-              <a:buNone/>
-            </a:pPr>
-            <a:r>
-              <a:rPr lang="en-US" sz="1300" dirty="0">
-                <a:solidFill>
-                  <a:srgbClr val="2D3748"/>
-                </a:solidFill>
-                <a:latin typeface="Arial" pitchFamily="34" charset="0"/>
-                <a:ea typeface="Arial" pitchFamily="34" charset="-122"/>
-                <a:cs typeface="Arial" pitchFamily="34" charset="-120"/>
-              </a:rPr>
-              <a:t>Als een aanbieder zijn capaciteit uitbreidt:
-</a:t>
-            </a:r>
-            <a:pPr algn="l" marL="342900" indent="-342900">
-              <a:lnSpc>
-                <a:spcPct val="115000"/>
-              </a:lnSpc>
-              <a:buSzPct val="100000"/>
-              <a:buChar char="•"/>
-            </a:pPr>
-            <a:r>
-              <a:rPr lang="en-US" sz="1400" dirty="0">
-                <a:solidFill>
-                  <a:srgbClr val="2D3748"/>
-                </a:solidFill>
-                <a:latin typeface="Arial" pitchFamily="34" charset="0"/>
-                <a:ea typeface="Arial" pitchFamily="34" charset="-122"/>
-                <a:cs typeface="Arial" pitchFamily="34" charset="-120"/>
-              </a:rPr>
-              <a:t>Reactielijn verschuift
-</a:t>
-            </a:r>
-            <a:pPr algn="l" marL="342900" indent="-342900">
-              <a:lnSpc>
-                <a:spcPct val="115000"/>
-              </a:lnSpc>
-              <a:buSzPct val="100000"/>
-              <a:buChar char="•"/>
-            </a:pPr>
-            <a:r>
-              <a:rPr lang="en-US" sz="1400" dirty="0">
-                <a:solidFill>
-                  <a:srgbClr val="2D3748"/>
-                </a:solidFill>
-                <a:latin typeface="Arial" pitchFamily="34" charset="0"/>
-                <a:ea typeface="Arial" pitchFamily="34" charset="-122"/>
-                <a:cs typeface="Arial" pitchFamily="34" charset="-120"/>
-              </a:rPr>
-              <a:t>Evenwicht verandert
-</a:t>
-            </a:r>
-            <a:pPr algn="l" marL="342900" indent="-342900">
-              <a:lnSpc>
-                <a:spcPct val="115000"/>
-              </a:lnSpc>
-              <a:buSzPct val="100000"/>
-              <a:buChar char="•"/>
-            </a:pPr>
-            <a:r>
-              <a:rPr lang="en-US" sz="1400" dirty="0">
-                <a:solidFill>
-                  <a:srgbClr val="2D3748"/>
-                </a:solidFill>
-                <a:latin typeface="Arial" pitchFamily="34" charset="0"/>
-                <a:ea typeface="Arial" pitchFamily="34" charset="-122"/>
-                <a:cs typeface="Arial" pitchFamily="34" charset="-120"/>
-              </a:rPr>
-              <a:t>Q stijgt, P daalt
-</a:t>
-            </a:r>
-            <a:pPr algn="l" marL="342900" indent="-342900">
-              <a:lnSpc>
-                <a:spcPct val="115000"/>
-              </a:lnSpc>
-              <a:buSzPct val="100000"/>
-              <a:buChar char="•"/>
-            </a:pPr>
-            <a:r>
-              <a:rPr lang="en-US" sz="1400" dirty="0">
-                <a:solidFill>
-                  <a:srgbClr val="2D3748"/>
-                </a:solidFill>
-                <a:latin typeface="Arial" pitchFamily="34" charset="0"/>
-                <a:ea typeface="Arial" pitchFamily="34" charset="-122"/>
-                <a:cs typeface="Arial" pitchFamily="34" charset="-120"/>
-              </a:rPr>
-              <a:t>Surplus verschuift</a:t>
-            </a:r>
-            <a:endParaRPr lang="en-US" sz="1400" dirty="0"/>
-          </a:p>
-        </p:txBody>
-      </p:sp>
-    </p:spTree>
-  </p:cSld>
-  <p:clrMapOvr>
-    <a:masterClrMapping/>
-  </p:clrMapOvr>
-</p:sld>
-</file>
-
 <file path=ppt/slides/slide11.xml><?xml version="1.0" encoding="utf-8"?>
 <p:sld xmlns:a="http://schemas.openxmlformats.org/drawingml/2006/main" xmlns:r="http://schemas.openxmlformats.org/officeDocument/2006/relationships" xmlns:p="http://schemas.openxmlformats.org/presentationml/2006/main">
   <p:cSld name="Slide 11">
@@ -5518,84 +5046,6 @@
           </a:solidFill>
           <a:ln/>
         </p:spPr>
-      </p:sp>
-      <p:sp>
-        <p:nvSpPr>
-          <p:cNvPr id="25" name="Text 23"/>
-          <p:cNvSpPr/>
-          <p:nvPr/>
-        </p:nvSpPr>
-        <p:spPr>
-          <a:xfrm>
-            <a:off x="4937760" y="3566160"/>
-            <a:ext cx="3657600" cy="320040"/>
-          </a:xfrm>
-          <a:prstGeom prst="rect">
-            <a:avLst/>
-          </a:prstGeom>
-          <a:noFill/>
-          <a:ln/>
-        </p:spPr>
-        <p:txBody>
-          <a:bodyPr wrap="square" rtlCol="0" anchor="t"/>
-          <a:lstStyle/>
-          <a:p>
-            <a:pPr indent="0" marL="0">
-              <a:buNone/>
-            </a:pPr>
-            <a:r>
-              <a:rPr lang="en-US" sz="1500" b="1" dirty="0">
-                <a:solidFill>
-                  <a:srgbClr val="154360"/>
-                </a:solidFill>
-                <a:latin typeface="Arial" pitchFamily="34" charset="0"/>
-                <a:ea typeface="Arial" pitchFamily="34" charset="-122"/>
-                <a:cs typeface="Arial" pitchFamily="34" charset="-120"/>
-              </a:rPr>
-              <a:t>Cournot-duopolie oplossen</a:t>
-            </a:r>
-            <a:endParaRPr lang="en-US" sz="1500" dirty="0"/>
-          </a:p>
-        </p:txBody>
-      </p:sp>
-      <p:sp>
-        <p:nvSpPr>
-          <p:cNvPr id="26" name="Text 24"/>
-          <p:cNvSpPr/>
-          <p:nvPr/>
-        </p:nvSpPr>
-        <p:spPr>
-          <a:xfrm>
-            <a:off x="4937760" y="3931920"/>
-            <a:ext cx="3657600" cy="457200"/>
-          </a:xfrm>
-          <a:prstGeom prst="rect">
-            <a:avLst/>
-          </a:prstGeom>
-          <a:noFill/>
-          <a:ln/>
-        </p:spPr>
-        <p:txBody>
-          <a:bodyPr wrap="square" rtlCol="0" anchor="t"/>
-          <a:lstStyle/>
-          <a:p>
-            <a:pPr indent="0" marL="0">
-              <a:buNone/>
-            </a:pPr>
-            <a:r>
-              <a:rPr lang="en-US" sz="1300" dirty="0">
-                <a:solidFill>
-                  <a:srgbClr val="718096"/>
-                </a:solidFill>
-                <a:latin typeface="Arial" pitchFamily="34" charset="0"/>
-                <a:ea typeface="Arial" pitchFamily="34" charset="-122"/>
-                <a:cs typeface="Arial" pitchFamily="34" charset="-120"/>
-              </a:rPr>
-              <a:t>Reactielijnen en Nash-evenwicht</a:t>
-            </a:r>
-            <a:endParaRPr lang="en-US" sz="1300" dirty="0"/>
-          </a:p>
-        </p:txBody>
       </p:sp>
     </p:spTree>
   </p:cSld>
@@ -11806,752 +11256,6 @@
               <a:t>Het consumentensurplus wordt omgezet in producentensurplus (CS → PS)</a:t>
             </a:r>
             <a:endParaRPr lang="en-US" sz="1400" dirty="0"/>
-          </a:p>
-        </p:txBody>
-      </p:sp>
-    </p:spTree>
-  </p:cSld>
-  <p:clrMapOvr>
-    <a:masterClrMapping/>
-  </p:clrMapOvr>
-</p:sld>
-</file>
-
-<file path=ppt/slides/slide9.xml><?xml version="1.0" encoding="utf-8"?>
-<p:sld xmlns:a="http://schemas.openxmlformats.org/drawingml/2006/main" xmlns:r="http://schemas.openxmlformats.org/officeDocument/2006/relationships" xmlns:p="http://schemas.openxmlformats.org/presentationml/2006/main">
-  <p:cSld name="Slide 9">
-    <p:spTree>
-      <p:nvGrpSpPr>
-        <p:cNvPr id="1" name=""/>
-        <p:cNvGrpSpPr/>
-        <p:nvPr/>
-      </p:nvGrpSpPr>
-      <p:grpSpPr>
-        <a:xfrm>
-          <a:off x="0" y="0"/>
-          <a:ext cx="0" cy="0"/>
-          <a:chOff x="0" y="0"/>
-          <a:chExt cx="0" cy="0"/>
-        </a:xfrm>
-      </p:grpSpPr>
-      <p:sp>
-        <p:nvSpPr>
-          <p:cNvPr id="2" name="Text 0"/>
-          <p:cNvSpPr/>
-          <p:nvPr/>
-        </p:nvSpPr>
-        <p:spPr>
-          <a:xfrm>
-            <a:off x="457200" y="0"/>
-            <a:ext cx="8229600" cy="685800"/>
-          </a:xfrm>
-          <a:prstGeom prst="rect">
-            <a:avLst/>
-          </a:prstGeom>
-          <a:noFill/>
-          <a:ln/>
-        </p:spPr>
-        <p:txBody>
-          <a:bodyPr wrap="square" rtlCol="0" anchor="ctr"/>
-          <a:lstStyle/>
-          <a:p>
-            <a:pPr indent="0" marL="0">
-              <a:buNone/>
-            </a:pPr>
-            <a:r>
-              <a:rPr lang="en-US" sz="2400" b="1" dirty="0">
-                <a:solidFill>
-                  <a:srgbClr val="FFFFFF"/>
-                </a:solidFill>
-                <a:latin typeface="Arial" pitchFamily="34" charset="0"/>
-                <a:ea typeface="Arial" pitchFamily="34" charset="-122"/>
-                <a:cs typeface="Arial" pitchFamily="34" charset="-120"/>
-              </a:rPr>
-              <a:t>Cournot-duopolie: reactielijnen</a:t>
-            </a:r>
-            <a:endParaRPr lang="en-US" sz="2400" dirty="0"/>
-          </a:p>
-        </p:txBody>
-      </p:sp>
-      <p:sp>
-        <p:nvSpPr>
-          <p:cNvPr id="3" name="Shape 1"/>
-          <p:cNvSpPr/>
-          <p:nvPr/>
-        </p:nvSpPr>
-        <p:spPr>
-          <a:xfrm>
-            <a:off x="914400" y="1005840"/>
-            <a:ext cx="7315200" cy="457200"/>
-          </a:xfrm>
-          <a:prstGeom prst="rect">
-            <a:avLst>
-              <a:gd name="adj" fmla="val 10000"/>
-            </a:avLst>
-          </a:prstGeom>
-          <a:solidFill>
-            <a:srgbClr val="F9F6F1"/>
-          </a:solidFill>
-          <a:ln w="12700">
-            <a:solidFill>
-              <a:srgbClr val="1A5276"/>
-            </a:solidFill>
-            <a:prstDash val="solid"/>
-          </a:ln>
-          <a:effectLst>
-            <a:outerShdw sx="100000" sy="100000" kx="0" ky="0" algn="bl" rotWithShape="0" blurRad="76200" dist="25400" dir="8100000">
-              <a:srgbClr val="000000">
-                <a:alpha val="10000"/>
-              </a:srgbClr>
-            </a:outerShdw>
-          </a:effectLst>
-        </p:spPr>
-      </p:sp>
-      <p:sp>
-        <p:nvSpPr>
-          <p:cNvPr id="4" name="Text 2"/>
-          <p:cNvSpPr/>
-          <p:nvPr/>
-        </p:nvSpPr>
-        <p:spPr>
-          <a:xfrm>
-            <a:off x="1024128" y="1005840"/>
-            <a:ext cx="320040" cy="457200"/>
-          </a:xfrm>
-          <a:prstGeom prst="rect">
-            <a:avLst/>
-          </a:prstGeom>
-          <a:noFill/>
-          <a:ln/>
-        </p:spPr>
-        <p:txBody>
-          <a:bodyPr wrap="square" rtlCol="0" anchor="ctr"/>
-          <a:lstStyle/>
-          <a:p>
-            <a:pPr indent="0" marL="0">
-              <a:buNone/>
-            </a:pPr>
-            <a:r>
-              <a:rPr lang="en-US" sz="1400" b="1" dirty="0">
-                <a:solidFill>
-                  <a:srgbClr val="1A5276"/>
-                </a:solidFill>
-                <a:latin typeface="Arial" pitchFamily="34" charset="0"/>
-                <a:ea typeface="Arial" pitchFamily="34" charset="-122"/>
-                <a:cs typeface="Arial" pitchFamily="34" charset="-120"/>
-              </a:rPr>
-              <a:t>1</a:t>
-            </a:r>
-            <a:endParaRPr lang="en-US" sz="1400" dirty="0"/>
-          </a:p>
-        </p:txBody>
-      </p:sp>
-      <p:sp>
-        <p:nvSpPr>
-          <p:cNvPr id="5" name="Text 3"/>
-          <p:cNvSpPr/>
-          <p:nvPr/>
-        </p:nvSpPr>
-        <p:spPr>
-          <a:xfrm>
-            <a:off x="1371600" y="1005840"/>
-            <a:ext cx="6720840" cy="457200"/>
-          </a:xfrm>
-          <a:prstGeom prst="rect">
-            <a:avLst/>
-          </a:prstGeom>
-          <a:noFill/>
-          <a:ln/>
-        </p:spPr>
-        <p:txBody>
-          <a:bodyPr wrap="square" rtlCol="0" anchor="ctr"/>
-          <a:lstStyle/>
-          <a:p>
-            <a:pPr indent="0" marL="0">
-              <a:buNone/>
-            </a:pPr>
-            <a:r>
-              <a:rPr lang="en-US" sz="1400" dirty="0">
-                <a:solidFill>
-                  <a:srgbClr val="2D3748"/>
-                </a:solidFill>
-                <a:latin typeface="Arial" pitchFamily="34" charset="0"/>
-                <a:ea typeface="Arial" pitchFamily="34" charset="-122"/>
-                <a:cs typeface="Arial" pitchFamily="34" charset="-120"/>
-              </a:rPr>
-              <a:t>Stel p op als functie van q₁ en q₂ (uit Qv)</a:t>
-            </a:r>
-            <a:endParaRPr lang="en-US" sz="1400" dirty="0"/>
-          </a:p>
-        </p:txBody>
-      </p:sp>
-      <p:sp>
-        <p:nvSpPr>
-          <p:cNvPr id="6" name="Text 4"/>
-          <p:cNvSpPr/>
-          <p:nvPr/>
-        </p:nvSpPr>
-        <p:spPr>
-          <a:xfrm>
-            <a:off x="914400" y="1463040"/>
-            <a:ext cx="7315200" cy="137160"/>
-          </a:xfrm>
-          <a:prstGeom prst="rect">
-            <a:avLst/>
-          </a:prstGeom>
-          <a:noFill/>
-          <a:ln/>
-        </p:spPr>
-        <p:txBody>
-          <a:bodyPr wrap="square" rtlCol="0" anchor="ctr"/>
-          <a:lstStyle/>
-          <a:p>
-            <a:pPr algn="ctr" indent="0" marL="0">
-              <a:buNone/>
-            </a:pPr>
-            <a:r>
-              <a:rPr lang="en-US" sz="1200" b="1" dirty="0">
-                <a:solidFill>
-                  <a:srgbClr val="1A5276"/>
-                </a:solidFill>
-                <a:latin typeface="Arial" pitchFamily="34" charset="0"/>
-                <a:ea typeface="Arial" pitchFamily="34" charset="-122"/>
-                <a:cs typeface="Arial" pitchFamily="34" charset="-120"/>
-              </a:rPr>
-              <a:t>↓</a:t>
-            </a:r>
-            <a:endParaRPr lang="en-US" sz="1200" dirty="0"/>
-          </a:p>
-        </p:txBody>
-      </p:sp>
-      <p:sp>
-        <p:nvSpPr>
-          <p:cNvPr id="7" name="Shape 5"/>
-          <p:cNvSpPr/>
-          <p:nvPr/>
-        </p:nvSpPr>
-        <p:spPr>
-          <a:xfrm>
-            <a:off x="914400" y="1600200"/>
-            <a:ext cx="7315200" cy="457200"/>
-          </a:xfrm>
-          <a:prstGeom prst="rect">
-            <a:avLst>
-              <a:gd name="adj" fmla="val 10000"/>
-            </a:avLst>
-          </a:prstGeom>
-          <a:solidFill>
-            <a:srgbClr val="F9F6F1"/>
-          </a:solidFill>
-          <a:ln w="12700">
-            <a:solidFill>
-              <a:srgbClr val="1A5276"/>
-            </a:solidFill>
-            <a:prstDash val="solid"/>
-          </a:ln>
-          <a:effectLst>
-            <a:outerShdw sx="100000" sy="100000" kx="0" ky="0" algn="bl" rotWithShape="0" blurRad="76200" dist="25400" dir="8100000">
-              <a:srgbClr val="000000">
-                <a:alpha val="10000"/>
-              </a:srgbClr>
-            </a:outerShdw>
-          </a:effectLst>
-        </p:spPr>
-      </p:sp>
-      <p:sp>
-        <p:nvSpPr>
-          <p:cNvPr id="8" name="Text 6"/>
-          <p:cNvSpPr/>
-          <p:nvPr/>
-        </p:nvSpPr>
-        <p:spPr>
-          <a:xfrm>
-            <a:off x="1024128" y="1600200"/>
-            <a:ext cx="320040" cy="457200"/>
-          </a:xfrm>
-          <a:prstGeom prst="rect">
-            <a:avLst/>
-          </a:prstGeom>
-          <a:noFill/>
-          <a:ln/>
-        </p:spPr>
-        <p:txBody>
-          <a:bodyPr wrap="square" rtlCol="0" anchor="ctr"/>
-          <a:lstStyle/>
-          <a:p>
-            <a:pPr indent="0" marL="0">
-              <a:buNone/>
-            </a:pPr>
-            <a:r>
-              <a:rPr lang="en-US" sz="1400" b="1" dirty="0">
-                <a:solidFill>
-                  <a:srgbClr val="1A5276"/>
-                </a:solidFill>
-                <a:latin typeface="Arial" pitchFamily="34" charset="0"/>
-                <a:ea typeface="Arial" pitchFamily="34" charset="-122"/>
-                <a:cs typeface="Arial" pitchFamily="34" charset="-120"/>
-              </a:rPr>
-              <a:t>2</a:t>
-            </a:r>
-            <a:endParaRPr lang="en-US" sz="1400" dirty="0"/>
-          </a:p>
-        </p:txBody>
-      </p:sp>
-      <p:sp>
-        <p:nvSpPr>
-          <p:cNvPr id="9" name="Text 7"/>
-          <p:cNvSpPr/>
-          <p:nvPr/>
-        </p:nvSpPr>
-        <p:spPr>
-          <a:xfrm>
-            <a:off x="1371600" y="1600200"/>
-            <a:ext cx="6720840" cy="457200"/>
-          </a:xfrm>
-          <a:prstGeom prst="rect">
-            <a:avLst/>
-          </a:prstGeom>
-          <a:noFill/>
-          <a:ln/>
-        </p:spPr>
-        <p:txBody>
-          <a:bodyPr wrap="square" rtlCol="0" anchor="ctr"/>
-          <a:lstStyle/>
-          <a:p>
-            <a:pPr indent="0" marL="0">
-              <a:buNone/>
-            </a:pPr>
-            <a:r>
-              <a:rPr lang="en-US" sz="1400" dirty="0">
-                <a:solidFill>
-                  <a:srgbClr val="2D3748"/>
-                </a:solidFill>
-                <a:latin typeface="Arial" pitchFamily="34" charset="0"/>
-                <a:ea typeface="Arial" pitchFamily="34" charset="-122"/>
-                <a:cs typeface="Arial" pitchFamily="34" charset="-120"/>
-              </a:rPr>
-              <a:t>Bereken MO per aanbieder (afhankelijk van q₁ en q₂)</a:t>
-            </a:r>
-            <a:endParaRPr lang="en-US" sz="1400" dirty="0"/>
-          </a:p>
-        </p:txBody>
-      </p:sp>
-      <p:sp>
-        <p:nvSpPr>
-          <p:cNvPr id="10" name="Text 8"/>
-          <p:cNvSpPr/>
-          <p:nvPr/>
-        </p:nvSpPr>
-        <p:spPr>
-          <a:xfrm>
-            <a:off x="914400" y="2057400"/>
-            <a:ext cx="7315200" cy="137160"/>
-          </a:xfrm>
-          <a:prstGeom prst="rect">
-            <a:avLst/>
-          </a:prstGeom>
-          <a:noFill/>
-          <a:ln/>
-        </p:spPr>
-        <p:txBody>
-          <a:bodyPr wrap="square" rtlCol="0" anchor="ctr"/>
-          <a:lstStyle/>
-          <a:p>
-            <a:pPr algn="ctr" indent="0" marL="0">
-              <a:buNone/>
-            </a:pPr>
-            <a:r>
-              <a:rPr lang="en-US" sz="1200" b="1" dirty="0">
-                <a:solidFill>
-                  <a:srgbClr val="1A5276"/>
-                </a:solidFill>
-                <a:latin typeface="Arial" pitchFamily="34" charset="0"/>
-                <a:ea typeface="Arial" pitchFamily="34" charset="-122"/>
-                <a:cs typeface="Arial" pitchFamily="34" charset="-120"/>
-              </a:rPr>
-              <a:t>↓</a:t>
-            </a:r>
-            <a:endParaRPr lang="en-US" sz="1200" dirty="0"/>
-          </a:p>
-        </p:txBody>
-      </p:sp>
-      <p:sp>
-        <p:nvSpPr>
-          <p:cNvPr id="11" name="Shape 9"/>
-          <p:cNvSpPr/>
-          <p:nvPr/>
-        </p:nvSpPr>
-        <p:spPr>
-          <a:xfrm>
-            <a:off x="914400" y="2194560"/>
-            <a:ext cx="7315200" cy="457200"/>
-          </a:xfrm>
-          <a:prstGeom prst="rect">
-            <a:avLst>
-              <a:gd name="adj" fmla="val 10000"/>
-            </a:avLst>
-          </a:prstGeom>
-          <a:solidFill>
-            <a:srgbClr val="F9F6F1"/>
-          </a:solidFill>
-          <a:ln w="12700">
-            <a:solidFill>
-              <a:srgbClr val="1A5276"/>
-            </a:solidFill>
-            <a:prstDash val="solid"/>
-          </a:ln>
-          <a:effectLst>
-            <a:outerShdw sx="100000" sy="100000" kx="0" ky="0" algn="bl" rotWithShape="0" blurRad="76200" dist="25400" dir="8100000">
-              <a:srgbClr val="000000">
-                <a:alpha val="10000"/>
-              </a:srgbClr>
-            </a:outerShdw>
-          </a:effectLst>
-        </p:spPr>
-      </p:sp>
-      <p:sp>
-        <p:nvSpPr>
-          <p:cNvPr id="12" name="Text 10"/>
-          <p:cNvSpPr/>
-          <p:nvPr/>
-        </p:nvSpPr>
-        <p:spPr>
-          <a:xfrm>
-            <a:off x="1024128" y="2194560"/>
-            <a:ext cx="320040" cy="457200"/>
-          </a:xfrm>
-          <a:prstGeom prst="rect">
-            <a:avLst/>
-          </a:prstGeom>
-          <a:noFill/>
-          <a:ln/>
-        </p:spPr>
-        <p:txBody>
-          <a:bodyPr wrap="square" rtlCol="0" anchor="ctr"/>
-          <a:lstStyle/>
-          <a:p>
-            <a:pPr indent="0" marL="0">
-              <a:buNone/>
-            </a:pPr>
-            <a:r>
-              <a:rPr lang="en-US" sz="1400" b="1" dirty="0">
-                <a:solidFill>
-                  <a:srgbClr val="1A5276"/>
-                </a:solidFill>
-                <a:latin typeface="Arial" pitchFamily="34" charset="0"/>
-                <a:ea typeface="Arial" pitchFamily="34" charset="-122"/>
-                <a:cs typeface="Arial" pitchFamily="34" charset="-120"/>
-              </a:rPr>
-              <a:t>3</a:t>
-            </a:r>
-            <a:endParaRPr lang="en-US" sz="1400" dirty="0"/>
-          </a:p>
-        </p:txBody>
-      </p:sp>
-      <p:sp>
-        <p:nvSpPr>
-          <p:cNvPr id="13" name="Text 11"/>
-          <p:cNvSpPr/>
-          <p:nvPr/>
-        </p:nvSpPr>
-        <p:spPr>
-          <a:xfrm>
-            <a:off x="1371600" y="2194560"/>
-            <a:ext cx="6720840" cy="457200"/>
-          </a:xfrm>
-          <a:prstGeom prst="rect">
-            <a:avLst/>
-          </a:prstGeom>
-          <a:noFill/>
-          <a:ln/>
-        </p:spPr>
-        <p:txBody>
-          <a:bodyPr wrap="square" rtlCol="0" anchor="ctr"/>
-          <a:lstStyle/>
-          <a:p>
-            <a:pPr indent="0" marL="0">
-              <a:buNone/>
-            </a:pPr>
-            <a:r>
-              <a:rPr lang="en-US" sz="1400" dirty="0">
-                <a:solidFill>
-                  <a:srgbClr val="2D3748"/>
-                </a:solidFill>
-                <a:latin typeface="Arial" pitchFamily="34" charset="0"/>
-                <a:ea typeface="Arial" pitchFamily="34" charset="-122"/>
-                <a:cs typeface="Arial" pitchFamily="34" charset="-120"/>
-              </a:rPr>
-              <a:t>Stel MO = MK → reactielijn per aanbieder</a:t>
-            </a:r>
-            <a:endParaRPr lang="en-US" sz="1400" dirty="0"/>
-          </a:p>
-        </p:txBody>
-      </p:sp>
-      <p:sp>
-        <p:nvSpPr>
-          <p:cNvPr id="14" name="Text 12"/>
-          <p:cNvSpPr/>
-          <p:nvPr/>
-        </p:nvSpPr>
-        <p:spPr>
-          <a:xfrm>
-            <a:off x="914400" y="2651760"/>
-            <a:ext cx="7315200" cy="137160"/>
-          </a:xfrm>
-          <a:prstGeom prst="rect">
-            <a:avLst/>
-          </a:prstGeom>
-          <a:noFill/>
-          <a:ln/>
-        </p:spPr>
-        <p:txBody>
-          <a:bodyPr wrap="square" rtlCol="0" anchor="ctr"/>
-          <a:lstStyle/>
-          <a:p>
-            <a:pPr algn="ctr" indent="0" marL="0">
-              <a:buNone/>
-            </a:pPr>
-            <a:r>
-              <a:rPr lang="en-US" sz="1200" b="1" dirty="0">
-                <a:solidFill>
-                  <a:srgbClr val="1A5276"/>
-                </a:solidFill>
-                <a:latin typeface="Arial" pitchFamily="34" charset="0"/>
-                <a:ea typeface="Arial" pitchFamily="34" charset="-122"/>
-                <a:cs typeface="Arial" pitchFamily="34" charset="-120"/>
-              </a:rPr>
-              <a:t>↓</a:t>
-            </a:r>
-            <a:endParaRPr lang="en-US" sz="1200" dirty="0"/>
-          </a:p>
-        </p:txBody>
-      </p:sp>
-      <p:sp>
-        <p:nvSpPr>
-          <p:cNvPr id="15" name="Shape 13"/>
-          <p:cNvSpPr/>
-          <p:nvPr/>
-        </p:nvSpPr>
-        <p:spPr>
-          <a:xfrm>
-            <a:off x="914400" y="2788920"/>
-            <a:ext cx="7315200" cy="457200"/>
-          </a:xfrm>
-          <a:prstGeom prst="rect">
-            <a:avLst>
-              <a:gd name="adj" fmla="val 10000"/>
-            </a:avLst>
-          </a:prstGeom>
-          <a:solidFill>
-            <a:srgbClr val="F9F6F1"/>
-          </a:solidFill>
-          <a:ln w="12700">
-            <a:solidFill>
-              <a:srgbClr val="1A5276"/>
-            </a:solidFill>
-            <a:prstDash val="solid"/>
-          </a:ln>
-          <a:effectLst>
-            <a:outerShdw sx="100000" sy="100000" kx="0" ky="0" algn="bl" rotWithShape="0" blurRad="76200" dist="25400" dir="8100000">
-              <a:srgbClr val="000000">
-                <a:alpha val="10000"/>
-              </a:srgbClr>
-            </a:outerShdw>
-          </a:effectLst>
-        </p:spPr>
-      </p:sp>
-      <p:sp>
-        <p:nvSpPr>
-          <p:cNvPr id="16" name="Text 14"/>
-          <p:cNvSpPr/>
-          <p:nvPr/>
-        </p:nvSpPr>
-        <p:spPr>
-          <a:xfrm>
-            <a:off x="1024128" y="2788920"/>
-            <a:ext cx="320040" cy="457200"/>
-          </a:xfrm>
-          <a:prstGeom prst="rect">
-            <a:avLst/>
-          </a:prstGeom>
-          <a:noFill/>
-          <a:ln/>
-        </p:spPr>
-        <p:txBody>
-          <a:bodyPr wrap="square" rtlCol="0" anchor="ctr"/>
-          <a:lstStyle/>
-          <a:p>
-            <a:pPr indent="0" marL="0">
-              <a:buNone/>
-            </a:pPr>
-            <a:r>
-              <a:rPr lang="en-US" sz="1400" b="1" dirty="0">
-                <a:solidFill>
-                  <a:srgbClr val="1A5276"/>
-                </a:solidFill>
-                <a:latin typeface="Arial" pitchFamily="34" charset="0"/>
-                <a:ea typeface="Arial" pitchFamily="34" charset="-122"/>
-                <a:cs typeface="Arial" pitchFamily="34" charset="-120"/>
-              </a:rPr>
-              <a:t>4</a:t>
-            </a:r>
-            <a:endParaRPr lang="en-US" sz="1400" dirty="0"/>
-          </a:p>
-        </p:txBody>
-      </p:sp>
-      <p:sp>
-        <p:nvSpPr>
-          <p:cNvPr id="17" name="Text 15"/>
-          <p:cNvSpPr/>
-          <p:nvPr/>
-        </p:nvSpPr>
-        <p:spPr>
-          <a:xfrm>
-            <a:off x="1371600" y="2788920"/>
-            <a:ext cx="6720840" cy="457200"/>
-          </a:xfrm>
-          <a:prstGeom prst="rect">
-            <a:avLst/>
-          </a:prstGeom>
-          <a:noFill/>
-          <a:ln/>
-        </p:spPr>
-        <p:txBody>
-          <a:bodyPr wrap="square" rtlCol="0" anchor="ctr"/>
-          <a:lstStyle/>
-          <a:p>
-            <a:pPr indent="0" marL="0">
-              <a:buNone/>
-            </a:pPr>
-            <a:r>
-              <a:rPr lang="en-US" sz="1400" dirty="0">
-                <a:solidFill>
-                  <a:srgbClr val="2D3748"/>
-                </a:solidFill>
-                <a:latin typeface="Arial" pitchFamily="34" charset="0"/>
-                <a:ea typeface="Arial" pitchFamily="34" charset="-122"/>
-                <a:cs typeface="Arial" pitchFamily="34" charset="-120"/>
-              </a:rPr>
-              <a:t>Los het stelsel van reactielijnen op → q₁* en q₂*</a:t>
-            </a:r>
-            <a:endParaRPr lang="en-US" sz="1400" dirty="0"/>
-          </a:p>
-        </p:txBody>
-      </p:sp>
-      <p:sp>
-        <p:nvSpPr>
-          <p:cNvPr id="18" name="Shape 16"/>
-          <p:cNvSpPr/>
-          <p:nvPr/>
-        </p:nvSpPr>
-        <p:spPr>
-          <a:xfrm>
-            <a:off x="914400" y="3520440"/>
-            <a:ext cx="7315200" cy="1097280"/>
-          </a:xfrm>
-          <a:prstGeom prst="rect">
-            <a:avLst>
-              <a:gd name="adj" fmla="val 4167"/>
-            </a:avLst>
-          </a:prstGeom>
-          <a:solidFill>
-            <a:srgbClr val="EBF5FB"/>
-          </a:solidFill>
-          <a:ln/>
-          <a:effectLst>
-            <a:outerShdw sx="100000" sy="100000" kx="0" ky="0" algn="bl" rotWithShape="0" blurRad="76200" dist="25400" dir="8100000">
-              <a:srgbClr val="000000">
-                <a:alpha val="10000"/>
-              </a:srgbClr>
-            </a:outerShdw>
-          </a:effectLst>
-        </p:spPr>
-      </p:sp>
-      <p:sp>
-        <p:nvSpPr>
-          <p:cNvPr id="19" name="Shape 17"/>
-          <p:cNvSpPr/>
-          <p:nvPr/>
-        </p:nvSpPr>
-        <p:spPr>
-          <a:xfrm>
-            <a:off x="914400" y="3520440"/>
-            <a:ext cx="54864" cy="1097280"/>
-          </a:xfrm>
-          <a:prstGeom prst="rect">
-            <a:avLst/>
-          </a:prstGeom>
-          <a:solidFill>
-            <a:srgbClr val="1A5276"/>
-          </a:solidFill>
-          <a:ln/>
-        </p:spPr>
-      </p:sp>
-      <p:sp>
-        <p:nvSpPr>
-          <p:cNvPr id="20" name="Text 18"/>
-          <p:cNvSpPr/>
-          <p:nvPr/>
-        </p:nvSpPr>
-        <p:spPr>
-          <a:xfrm>
-            <a:off x="1143000" y="3520440"/>
-            <a:ext cx="6858000" cy="1097280"/>
-          </a:xfrm>
-          <a:prstGeom prst="rect">
-            <a:avLst/>
-          </a:prstGeom>
-          <a:noFill/>
-          <a:ln/>
-        </p:spPr>
-        <p:txBody>
-          <a:bodyPr wrap="square" rtlCol="0" anchor="ctr"/>
-          <a:lstStyle/>
-          <a:p>
-            <a:pPr indent="0" marL="0">
-              <a:buNone/>
-            </a:pPr>
-            <a:r>
-              <a:rPr lang="en-US" sz="1500" b="1" dirty="0">
-                <a:solidFill>
-                  <a:srgbClr val="1A5276"/>
-                </a:solidFill>
-                <a:latin typeface="Arial" pitchFamily="34" charset="0"/>
-                <a:ea typeface="Arial" pitchFamily="34" charset="-122"/>
-                <a:cs typeface="Arial" pitchFamily="34" charset="-120"/>
-              </a:rPr>
-              <a:t>Nash-evenwicht: </a:t>
-            </a:r>
-            <a:pPr indent="0" marL="0">
-              <a:buNone/>
-            </a:pPr>
-            <a:r>
-              <a:rPr lang="en-US" sz="1500" dirty="0">
-                <a:solidFill>
-                  <a:srgbClr val="2D3748"/>
-                </a:solidFill>
-                <a:latin typeface="Arial" pitchFamily="34" charset="0"/>
-                <a:ea typeface="Arial" pitchFamily="34" charset="-122"/>
-                <a:cs typeface="Arial" pitchFamily="34" charset="-120"/>
-              </a:rPr>
-              <a:t>geen aanbieder wil afwijken
-</a:t>
-            </a:r>
-            <a:pPr indent="0" marL="0">
-              <a:buNone/>
-            </a:pPr>
-            <a:r>
-              <a:rPr lang="en-US" sz="1300" dirty="0">
-                <a:solidFill>
-                  <a:srgbClr val="718096"/>
-                </a:solidFill>
-                <a:latin typeface="Arial" pitchFamily="34" charset="0"/>
-                <a:ea typeface="Arial" pitchFamily="34" charset="-122"/>
-                <a:cs typeface="Arial" pitchFamily="34" charset="-120"/>
-              </a:rPr>
-              <a:t>Bij symmetrisch duopolie: q₁* = q₂* (invullen in elkaars reactielijn)</a:t>
-            </a:r>
-            <a:endParaRPr lang="en-US" sz="1500" dirty="0"/>
           </a:p>
         </p:txBody>
       </p:sp>

</xml_diff>